<commit_message>
NomadPick: frontend, FastAPI backend, Playwright RPA, TiDB, path-based CI/CD, docs
- Frontend (HTML/CSS/Vanilla JS/Bootstrap 5) deployable to Netlify with offline snapshot
- FastAPI API (20 endpoints) + APScheduler, TiDB only (pytest uses nomadpick_test)
- RPA: Playwright human-like browser for Hanatour/Modetour/Ybtour live deals,
  pandas normalization (date ranges/lists), MOLIT domestic flight API (2026 path)
- Deploy: Dockerfile, render.yaml, docker-compose + Caddy, deploy.yml with
  path filters (frontend -> Netlify/Render/EC2, backend -> Render/EC2)
- Env: .env for local/EC2, Render dashboard env paste
- Docs: journals/deliverables (hwpx/pdf), presentation (pptx/pdf), md records

Generated with [Devin](https://devin.ai)

Co-Authored-By: Devin <158243242+devin-ai-integration[bot]@users.noreply.github.com>
</commit_message>
<xml_diff>
--- a/docs/프로젝트_발표자료.pptx
+++ b/docs/프로젝트_발표자료.pptx
@@ -17,6 +17,7 @@
     <p:sldId id="265" r:id="rId17"/>
     <p:sldId id="266" r:id="rId18"/>
     <p:sldId id="267" r:id="rId19"/>
+    <p:sldId id="270" r:id="rId22"/>
     <p:sldId id="268" r:id="rId20"/>
     <p:sldId id="269" r:id="rId21"/>
   </p:sldIdLst>
@@ -4456,7 +4457,7 @@
                 <a:ea typeface="맑은 고딕"/>
                 <a:cs typeface="맑은 고딕"/>
               </a:rPr>
-              <a:t>트래블핏 (TravelFit)</a:t>
+              <a:t>노마드픽 (NomadPick)</a:t>
             </a:r>
           </a:p>
         </p:txBody>
@@ -4887,7 +4888,7 @@
                 <a:ea typeface="맑은 고딕"/>
                 <a:cs typeface="맑은 고딕"/>
               </a:rPr>
-              <a:t>트래블핏(TravelFit) · Semi-Project · 3조</a:t>
+              <a:t>노마드픽(NomadPick) · Semi-Project · 3조</a:t>
             </a:r>
           </a:p>
         </p:txBody>
@@ -5049,7 +5050,7 @@
                           <a:ea typeface="맑은 고딕"/>
                           <a:cs typeface="맑은 고딕"/>
                         </a:rPr>
-                        <a:t>노랑풍선 목록이 비어 있게 수집</a:t>
+                        <a:t>모두투어 Access Denied·목록 0건</a:t>
                       </a:r>
                     </a:p>
                   </a:txBody>
@@ -5074,7 +5075,7 @@
                           <a:ea typeface="맑은 고딕"/>
                           <a:cs typeface="맑은 고딕"/>
                         </a:rPr>
-                        <a:t>JavaScript 동적 렌더링</a:t>
+                        <a:t>봇형 요청 차단·JS 렌더링</a:t>
                       </a:r>
                     </a:p>
                   </a:txBody>
@@ -5099,7 +5100,7 @@
                           <a:ea typeface="맑은 고딕"/>
                           <a:cs typeface="맑은 고딕"/>
                         </a:rPr>
-                        <a:t>서버 렌더링되는 특가 기획전 페이지로 수집 대상 변경</a:t>
+                        <a:t>Playwright 사람과 같은 브라우저 접근(UA·로케일·스크롤)</a:t>
                       </a:r>
                     </a:p>
                   </a:txBody>
@@ -5280,7 +5281,7 @@
                           <a:ea typeface="맑은 고딕"/>
                           <a:cs typeface="맑은 고딕"/>
                         </a:rPr>
-                        <a:t>모두투어 가격 중복 파싱</a:t>
+                        <a:t>노랑풍선 가격 중복 파싱</a:t>
                       </a:r>
                     </a:p>
                   </a:txBody>
@@ -5305,7 +5306,7 @@
                           <a:ea typeface="맑은 고딕"/>
                           <a:cs typeface="맑은 고딕"/>
                         </a:rPr>
-                        <a:t>유류할증료 포함가 동시 표기</a:t>
+                        <a:t>정상가·특가 동시 표기</a:t>
                       </a:r>
                     </a:p>
                   </a:txBody>
@@ -5330,7 +5331,7 @@
                           <a:ea typeface="맑은 고딕"/>
                           <a:cs typeface="맑은 고딕"/>
                         </a:rPr>
-                        <a:t>기본 판매가 셀렉터로 한정, 파서 테스트 추가</a:t>
+                        <a:t>특가(p.sale) 우선 셀렉터, 회귀 테스트</a:t>
                       </a:r>
                     </a:p>
                   </a:txBody>
@@ -5357,7 +5358,7 @@
                           <a:ea typeface="맑은 고딕"/>
                           <a:cs typeface="맑은 고딕"/>
                         </a:rPr>
-                        <a:t>여행경보 국가 매칭 실패</a:t>
+                        <a:t>국내선 항공편 매칭 실패</a:t>
                       </a:r>
                     </a:p>
                   </a:txBody>
@@ -5382,7 +5383,7 @@
                           <a:ea typeface="맑은 고딕"/>
                           <a:cs typeface="맑은 고딕"/>
                         </a:rPr>
-                        <a:t>미국/미합중국 등 국가명 차이</a:t>
+                        <a:t>제주/제주도 등 도시명 차이</a:t>
                       </a:r>
                     </a:p>
                   </a:txBody>
@@ -5407,7 +5408,7 @@
                           <a:ea typeface="맑은 고딕"/>
                           <a:cs typeface="맑은 고딕"/>
                         </a:rPr>
-                        <a:t>ISO 국가 코드 매핑 테이블 적용</a:t>
+                        <a:t>도시-공항 ID 매핑 테이블 적용</a:t>
                       </a:r>
                     </a:p>
                   </a:txBody>
@@ -5681,7 +5682,7 @@
                 <a:ea typeface="맑은 고딕"/>
                 <a:cs typeface="맑은 고딕"/>
               </a:rPr>
-              <a:t>트래블핏(TravelFit) · Semi-Project · 3조</a:t>
+              <a:t>노마드픽(NomadPick) · Semi-Project · 3조</a:t>
             </a:r>
           </a:p>
         </p:txBody>
@@ -5853,7 +5854,7 @@
                 <a:ea typeface="맑은 고딕"/>
                 <a:cs typeface="맑은 고딕"/>
               </a:rPr>
-              <a:t>82건</a:t>
+              <a:t>106건</a:t>
             </a:r>
           </a:p>
         </p:txBody>
@@ -5935,7 +5936,7 @@
                 <a:ea typeface="맑은 고딕"/>
                 <a:cs typeface="맑은 고딕"/>
               </a:rPr>
-              <a:t>1차 성공 79건, 결함 조치 후 전체 통과</a:t>
+              <a:t>1차 성공 103건, 결함 조치 후 전체 통과</a:t>
             </a:r>
           </a:p>
         </p:txBody>
@@ -6148,7 +6149,7 @@
                 <a:ea typeface="맑은 고딕"/>
                 <a:cs typeface="맑은 고딕"/>
               </a:rPr>
-              <a:t>가격 중복 파싱, 여행경보 매칭, 모바일 필터</a:t>
+              <a:t>가격 중복 파싱, 항공편 매칭, 모바일 필터</a:t>
             </a:r>
           </a:p>
         </p:txBody>
@@ -6772,7 +6773,7 @@
                           <a:ea typeface="맑은 고딕"/>
                           <a:cs typeface="맑은 고딕"/>
                         </a:rPr>
-                        <a:t>52</a:t>
+                        <a:t>76</a:t>
                       </a:r>
                     </a:p>
                   </a:txBody>
@@ -6797,7 +6798,7 @@
                           <a:ea typeface="맑은 고딕"/>
                           <a:cs typeface="맑은 고딕"/>
                         </a:rPr>
-                        <a:t>52</a:t>
+                        <a:t>76</a:t>
                       </a:r>
                     </a:p>
                   </a:txBody>
@@ -7172,7 +7173,7 @@
                 <a:ea typeface="맑은 고딕"/>
                 <a:cs typeface="맑은 고딕"/>
               </a:rPr>
-              <a:t>약 3분</a:t>
+              <a:t>약 3분 · nomadpick.duckdns.org</a:t>
             </a:r>
           </a:p>
         </p:txBody>
@@ -7248,7 +7249,7 @@
                 <a:ea typeface="맑은 고딕"/>
                 <a:cs typeface="맑은 고딕"/>
               </a:rPr>
-              <a:t>트래블핏(TravelFit) · Semi-Project · 3조</a:t>
+              <a:t>노마드픽(NomadPick) · Semi-Project · 3조</a:t>
             </a:r>
           </a:p>
         </p:txBody>
@@ -7793,7 +7794,7 @@
                 <a:ea typeface="맑은 고딕"/>
                 <a:cs typeface="맑은 고딕"/>
               </a:rPr>
-              <a:t>상품 상세: 30일 가격 추이, 여행경보 배지, 원 여행사 링크</a:t>
+              <a:t>상품 상세: 30일 가격 추이, 국내선 항공편(국토교통부), 원 여행사 링크</a:t>
             </a:r>
           </a:p>
         </p:txBody>
@@ -8309,7 +8310,7 @@
                 <a:ea typeface="맑은 고딕"/>
                 <a:cs typeface="맑은 고딕"/>
               </a:rPr>
-              <a:t>트래블핏(TravelFit) · Semi-Project · 3조</a:t>
+              <a:t>노마드픽(NomadPick) · Semi-Project · 3조</a:t>
             </a:r>
           </a:p>
         </p:txBody>
@@ -8350,7 +8351,7 @@
                 <a:ea typeface="맑은 고딕"/>
                 <a:cs typeface="맑은 고딕"/>
               </a:rPr>
-              <a:t>13</a:t>
+              <a:t>14</a:t>
             </a:r>
           </a:p>
         </p:txBody>
@@ -8804,7 +8805,7 @@
                           <a:ea typeface="맑은 고딕"/>
                           <a:cs typeface="맑은 고딕"/>
                         </a:rPr>
-                        <a:t>Render + EC2 + TiDB</a:t>
+                        <a:t>Netlify + Render + EC2 + TiDB</a:t>
                       </a:r>
                     </a:p>
                   </a:txBody>
@@ -8982,7 +8983,7 @@
                 <a:ea typeface="맑은 고딕"/>
                 <a:cs typeface="맑은 고딕"/>
               </a:rPr>
-              <a:t>  수집기 프레임워크·가격 스냅샷·Render/EC2 배포를 Final-Project에 재사용</a:t>
+              <a:t>  수집기 프레임워크·가격 스냅샷·Docker·Render/EC2 배포를 Final-Project에 재사용</a:t>
             </a:r>
           </a:p>
         </p:txBody>
@@ -9167,7 +9168,544 @@
                 <a:ea typeface="맑은 고딕"/>
                 <a:cs typeface="맑은 고딕"/>
               </a:rPr>
-              <a:t>트래블핏(TravelFit) · Semi-Project · 3조</a:t>
+              <a:t>노마드픽(NomadPick) · Semi-Project · 3조</a:t>
+            </a:r>
+          </a:p>
+        </p:txBody>
+      </p:sp>
+    </p:spTree>
+  </p:cSld>
+  <p:clrMapOvr>
+    <a:masterClrMapping/>
+  </p:clrMapOvr>
+</p:sld>
+</file>
+
+<file path=ppt/slides/slide15.xml><?xml version="1.0" encoding="utf-8"?>
+<p:sld xmlns:a="http://schemas.openxmlformats.org/drawingml/2006/main" xmlns:p="http://schemas.openxmlformats.org/presentationml/2006/main" xmlns:r="http://schemas.openxmlformats.org/officeDocument/2006/relationships">
+  <p:cSld>
+    <p:spTree>
+      <p:nvGrpSpPr>
+        <p:cNvPr id="1" name=""/>
+        <p:cNvGrpSpPr/>
+        <p:nvPr/>
+      </p:nvGrpSpPr>
+      <p:grpSpPr/>
+      <p:sp>
+        <p:nvSpPr>
+          <p:cNvPr id="2" name="Rectangle 1"/>
+          <p:cNvSpPr/>
+          <p:nvPr/>
+        </p:nvSpPr>
+        <p:spPr>
+          <a:xfrm>
+            <a:off x="0" y="0"/>
+            <a:ext cx="12191695" cy="109728"/>
+          </a:xfrm>
+          <a:prstGeom prst="rect">
+            <a:avLst/>
+          </a:prstGeom>
+          <a:solidFill>
+            <a:srgbClr val="0D6EFD"/>
+          </a:solidFill>
+          <a:ln>
+            <a:noFill/>
+          </a:ln>
+          <a:effectLst/>
+        </p:spPr>
+        <p:style>
+          <a:lnRef idx="1">
+            <a:schemeClr val="accent1"/>
+          </a:lnRef>
+          <a:fillRef idx="3">
+            <a:schemeClr val="accent1"/>
+          </a:fillRef>
+          <a:effectRef idx="2">
+            <a:schemeClr val="accent1"/>
+          </a:effectRef>
+          <a:fontRef idx="minor">
+            <a:schemeClr val="lt1"/>
+          </a:fontRef>
+        </p:style>
+        <p:txBody>
+          <a:bodyPr rtlCol="0" anchor="ctr"/>
+          <a:lstStyle/>
+          <a:p>
+            <a:pPr algn="ctr"/>
+          </a:p>
+        </p:txBody>
+      </p:sp>
+      <p:sp>
+        <p:nvSpPr>
+          <p:cNvPr id="3" name="Rectangle 2"/>
+          <p:cNvSpPr/>
+          <p:nvPr/>
+        </p:nvSpPr>
+        <p:spPr>
+          <a:xfrm>
+            <a:off x="548640" y="457200"/>
+            <a:ext cx="109728" cy="566928"/>
+          </a:xfrm>
+          <a:prstGeom prst="rect">
+            <a:avLst/>
+          </a:prstGeom>
+          <a:solidFill>
+            <a:srgbClr val="0D6EFD"/>
+          </a:solidFill>
+          <a:ln>
+            <a:noFill/>
+          </a:ln>
+          <a:effectLst/>
+        </p:spPr>
+        <p:style>
+          <a:lnRef idx="1">
+            <a:schemeClr val="accent1"/>
+          </a:lnRef>
+          <a:fillRef idx="3">
+            <a:schemeClr val="accent1"/>
+          </a:fillRef>
+          <a:effectRef idx="2">
+            <a:schemeClr val="accent1"/>
+          </a:effectRef>
+          <a:fontRef idx="minor">
+            <a:schemeClr val="lt1"/>
+          </a:fontRef>
+        </p:style>
+        <p:txBody>
+          <a:bodyPr rtlCol="0" anchor="ctr"/>
+          <a:lstStyle/>
+          <a:p>
+            <a:pPr algn="ctr"/>
+          </a:p>
+        </p:txBody>
+      </p:sp>
+      <p:sp>
+        <p:nvSpPr>
+          <p:cNvPr id="4" name="TextBox 3"/>
+          <p:cNvSpPr txBox="1"/>
+          <p:nvPr/>
+        </p:nvSpPr>
+        <p:spPr>
+          <a:xfrm>
+            <a:off x="777240" y="384048"/>
+            <a:ext cx="9144000" cy="731520"/>
+          </a:xfrm>
+          <a:prstGeom prst="rect">
+            <a:avLst/>
+          </a:prstGeom>
+          <a:noFill/>
+        </p:spPr>
+        <p:txBody>
+          <a:bodyPr wrap="square" anchor="ctr" lIns="45720" rIns="45720">
+            <a:spAutoFit/>
+          </a:bodyPr>
+          <a:lstStyle/>
+          <a:p>
+            <a:pPr algn="l">
+              <a:spcAft>
+                <a:spcPts val="600"/>
+              </a:spcAft>
+            </a:pPr>
+            <a:r>
+              <a:rPr sz="3000" b="1">
+                <a:solidFill>
+                  <a:srgbClr val="222222"/>
+                </a:solidFill>
+                <a:latin typeface="맑은 고딕"/>
+                <a:ea typeface="맑은 고딕"/>
+                <a:cs typeface="맑은 고딕"/>
+              </a:rPr>
+              <a:t>주요 화면</a:t>
+            </a:r>
+          </a:p>
+        </p:txBody>
+      </p:sp>
+      <p:sp>
+        <p:nvSpPr>
+          <p:cNvPr id="5" name="TextBox 4"/>
+          <p:cNvSpPr txBox="1"/>
+          <p:nvPr/>
+        </p:nvSpPr>
+        <p:spPr>
+          <a:xfrm>
+            <a:off x="7589520" y="457200"/>
+            <a:ext cx="4114800" cy="548640"/>
+          </a:xfrm>
+          <a:prstGeom prst="rect">
+            <a:avLst/>
+          </a:prstGeom>
+          <a:noFill/>
+        </p:spPr>
+        <p:txBody>
+          <a:bodyPr wrap="square" anchor="ctr" lIns="45720" rIns="45720">
+            <a:spAutoFit/>
+          </a:bodyPr>
+          <a:lstStyle/>
+          <a:p>
+            <a:pPr algn="r">
+              <a:spcAft>
+                <a:spcPts val="600"/>
+              </a:spcAft>
+            </a:pPr>
+            <a:r>
+              <a:rPr sz="1400" b="0">
+                <a:solidFill>
+                  <a:srgbClr val="666666"/>
+                </a:solidFill>
+                <a:latin typeface="맑은 고딕"/>
+                <a:ea typeface="맑은 고딕"/>
+                <a:cs typeface="맑은 고딕"/>
+              </a:rPr>
+              <a:t>로컬 통합 테스트 화면</a:t>
+            </a:r>
+          </a:p>
+        </p:txBody>
+      </p:sp>
+      <p:cxnSp>
+        <p:nvCxnSpPr>
+          <p:cNvPr id="6" name="Connector 5"/>
+          <p:cNvCxnSpPr/>
+          <p:nvPr/>
+        </p:nvCxnSpPr>
+        <p:spPr>
+          <a:xfrm>
+            <a:off x="548640" y="1188720"/>
+            <a:ext cx="11094415" cy="0"/>
+          </a:xfrm>
+          <a:prstGeom prst="line">
+            <a:avLst/>
+          </a:prstGeom>
+          <a:ln>
+            <a:solidFill>
+              <a:srgbClr val="DDDDDD"/>
+            </a:solidFill>
+          </a:ln>
+        </p:spPr>
+        <p:style>
+          <a:lnRef idx="2">
+            <a:schemeClr val="accent1"/>
+          </a:lnRef>
+          <a:fillRef idx="0">
+            <a:schemeClr val="accent1"/>
+          </a:fillRef>
+          <a:effectRef idx="1">
+            <a:schemeClr val="accent1"/>
+          </a:effectRef>
+          <a:fontRef idx="minor">
+            <a:schemeClr val="tx1"/>
+          </a:fontRef>
+        </p:style>
+      </p:cxnSp>
+      <p:sp>
+        <p:nvSpPr>
+          <p:cNvPr id="7" name="TextBox 6"/>
+          <p:cNvSpPr txBox="1"/>
+          <p:nvPr/>
+        </p:nvSpPr>
+        <p:spPr>
+          <a:xfrm>
+            <a:off x="548640" y="6400800"/>
+            <a:ext cx="8229600" cy="320040"/>
+          </a:xfrm>
+          <a:prstGeom prst="rect">
+            <a:avLst/>
+          </a:prstGeom>
+          <a:noFill/>
+        </p:spPr>
+        <p:txBody>
+          <a:bodyPr wrap="square" anchor="t" lIns="45720" rIns="45720">
+            <a:spAutoFit/>
+          </a:bodyPr>
+          <a:lstStyle/>
+          <a:p>
+            <a:pPr algn="l">
+              <a:spcAft>
+                <a:spcPts val="600"/>
+              </a:spcAft>
+            </a:pPr>
+            <a:r>
+              <a:rPr sz="1000" b="0">
+                <a:solidFill>
+                  <a:srgbClr val="666666"/>
+                </a:solidFill>
+                <a:latin typeface="맑은 고딕"/>
+                <a:ea typeface="맑은 고딕"/>
+                <a:cs typeface="맑은 고딕"/>
+              </a:rPr>
+              <a:t>노마드픽(NomadPick) · Semi-Project · 3조</a:t>
+            </a:r>
+          </a:p>
+        </p:txBody>
+      </p:sp>
+      <p:sp>
+        <p:nvSpPr>
+          <p:cNvPr id="8" name="TextBox 7"/>
+          <p:cNvSpPr txBox="1"/>
+          <p:nvPr/>
+        </p:nvSpPr>
+        <p:spPr>
+          <a:xfrm>
+            <a:off x="10728655" y="6400800"/>
+            <a:ext cx="914400" cy="320040"/>
+          </a:xfrm>
+          <a:prstGeom prst="rect">
+            <a:avLst/>
+          </a:prstGeom>
+          <a:noFill/>
+        </p:spPr>
+        <p:txBody>
+          <a:bodyPr wrap="square" anchor="t" lIns="45720" rIns="45720">
+            <a:spAutoFit/>
+          </a:bodyPr>
+          <a:lstStyle/>
+          <a:p>
+            <a:pPr algn="r">
+              <a:spcAft>
+                <a:spcPts val="600"/>
+              </a:spcAft>
+            </a:pPr>
+            <a:r>
+              <a:rPr sz="1000" b="0">
+                <a:solidFill>
+                  <a:srgbClr val="666666"/>
+                </a:solidFill>
+                <a:latin typeface="맑은 고딕"/>
+                <a:ea typeface="맑은 고딕"/>
+                <a:cs typeface="맑은 고딕"/>
+              </a:rPr>
+              <a:t>13</a:t>
+            </a:r>
+          </a:p>
+        </p:txBody>
+      </p:sp>
+      <p:pic>
+        <p:nvPicPr>
+          <p:cNvPr id="9" name="Picture 8" descr="image.png"/>
+          <p:cNvPicPr>
+            <a:picLocks noChangeAspect="1"/>
+          </p:cNvPicPr>
+          <p:nvPr/>
+        </p:nvPicPr>
+        <p:blipFill>
+          <a:blip r:embed="rId2"/>
+          <a:stretch>
+            <a:fillRect/>
+          </a:stretch>
+        </p:blipFill>
+        <p:spPr>
+          <a:xfrm>
+            <a:off x="548640" y="1325880"/>
+            <a:ext cx="5455767" cy="2080260"/>
+          </a:xfrm>
+          <a:prstGeom prst="rect">
+            <a:avLst/>
+          </a:prstGeom>
+          <a:ln>
+            <a:solidFill>
+              <a:srgbClr val="DEE2E6"/>
+            </a:solidFill>
+          </a:ln>
+        </p:spPr>
+      </p:pic>
+      <p:sp>
+        <p:nvSpPr>
+          <p:cNvPr id="10" name="TextBox 9"/>
+          <p:cNvSpPr txBox="1"/>
+          <p:nvPr/>
+        </p:nvSpPr>
+        <p:spPr>
+          <a:xfrm>
+            <a:off x="548640" y="3406140"/>
+            <a:ext cx="5455767" cy="320040"/>
+          </a:xfrm>
+          <a:prstGeom prst="rect">
+            <a:avLst/>
+          </a:prstGeom>
+          <a:noFill/>
+        </p:spPr>
+        <p:txBody>
+          <a:bodyPr wrap="none">
+            <a:spAutoFit/>
+          </a:bodyPr>
+          <a:lstStyle/>
+          <a:p>
+            <a:r>
+              <a:rPr sz="1200" b="1"/>
+              <a:t>오늘의 특가 (SC-04)</a:t>
+            </a:r>
+          </a:p>
+        </p:txBody>
+      </p:sp>
+      <p:pic>
+        <p:nvPicPr>
+          <p:cNvPr id="11" name="Picture 10" descr="image.png"/>
+          <p:cNvPicPr>
+            <a:picLocks noChangeAspect="1"/>
+          </p:cNvPicPr>
+          <p:nvPr/>
+        </p:nvPicPr>
+        <p:blipFill>
+          <a:blip r:embed="rId3"/>
+          <a:stretch>
+            <a:fillRect/>
+          </a:stretch>
+        </p:blipFill>
+        <p:spPr>
+          <a:xfrm>
+            <a:off x="6187287" y="1325880"/>
+            <a:ext cx="5455767" cy="2080260"/>
+          </a:xfrm>
+          <a:prstGeom prst="rect">
+            <a:avLst/>
+          </a:prstGeom>
+          <a:ln>
+            <a:solidFill>
+              <a:srgbClr val="DEE2E6"/>
+            </a:solidFill>
+          </a:ln>
+        </p:spPr>
+      </p:pic>
+      <p:sp>
+        <p:nvSpPr>
+          <p:cNvPr id="12" name="TextBox 11"/>
+          <p:cNvSpPr txBox="1"/>
+          <p:nvPr/>
+        </p:nvSpPr>
+        <p:spPr>
+          <a:xfrm>
+            <a:off x="6187287" y="3406140"/>
+            <a:ext cx="5455767" cy="320040"/>
+          </a:xfrm>
+          <a:prstGeom prst="rect">
+            <a:avLst/>
+          </a:prstGeom>
+          <a:noFill/>
+        </p:spPr>
+        <p:txBody>
+          <a:bodyPr wrap="none">
+            <a:spAutoFit/>
+          </a:bodyPr>
+          <a:lstStyle/>
+          <a:p>
+            <a:r>
+              <a:rPr sz="1200" b="1"/>
+              <a:t>맞춤 추천 Top 10 (SC-05)</a:t>
+            </a:r>
+          </a:p>
+        </p:txBody>
+      </p:sp>
+      <p:pic>
+        <p:nvPicPr>
+          <p:cNvPr id="13" name="Picture 12" descr="image.png"/>
+          <p:cNvPicPr>
+            <a:picLocks noChangeAspect="1"/>
+          </p:cNvPicPr>
+          <p:nvPr/>
+        </p:nvPicPr>
+        <p:blipFill>
+          <a:blip r:embed="rId4"/>
+          <a:stretch>
+            <a:fillRect/>
+          </a:stretch>
+        </p:blipFill>
+        <p:spPr>
+          <a:xfrm>
+            <a:off x="548640" y="3909060"/>
+            <a:ext cx="5455767" cy="2080260"/>
+          </a:xfrm>
+          <a:prstGeom prst="rect">
+            <a:avLst/>
+          </a:prstGeom>
+          <a:ln>
+            <a:solidFill>
+              <a:srgbClr val="DEE2E6"/>
+            </a:solidFill>
+          </a:ln>
+        </p:spPr>
+      </p:pic>
+      <p:sp>
+        <p:nvSpPr>
+          <p:cNvPr id="14" name="TextBox 13"/>
+          <p:cNvSpPr txBox="1"/>
+          <p:nvPr/>
+        </p:nvSpPr>
+        <p:spPr>
+          <a:xfrm>
+            <a:off x="548640" y="5989320"/>
+            <a:ext cx="5455767" cy="320040"/>
+          </a:xfrm>
+          <a:prstGeom prst="rect">
+            <a:avLst/>
+          </a:prstGeom>
+          <a:noFill/>
+        </p:spPr>
+        <p:txBody>
+          <a:bodyPr wrap="none">
+            <a:spAutoFit/>
+          </a:bodyPr>
+          <a:lstStyle/>
+          <a:p>
+            <a:r>
+              <a:rPr sz="1200" b="1"/>
+              <a:t>상품 상세 · 가격 추이 · 국내선 항공편 (SC-06)</a:t>
+            </a:r>
+          </a:p>
+        </p:txBody>
+      </p:sp>
+      <p:pic>
+        <p:nvPicPr>
+          <p:cNvPr id="15" name="Picture 14" descr="image.png"/>
+          <p:cNvPicPr>
+            <a:picLocks noChangeAspect="1"/>
+          </p:cNvPicPr>
+          <p:nvPr/>
+        </p:nvPicPr>
+        <p:blipFill>
+          <a:blip r:embed="rId5"/>
+          <a:stretch>
+            <a:fillRect/>
+          </a:stretch>
+        </p:blipFill>
+        <p:spPr>
+          <a:xfrm>
+            <a:off x="6187287" y="3909060"/>
+            <a:ext cx="5455767" cy="2080260"/>
+          </a:xfrm>
+          <a:prstGeom prst="rect">
+            <a:avLst/>
+          </a:prstGeom>
+          <a:ln>
+            <a:solidFill>
+              <a:srgbClr val="DEE2E6"/>
+            </a:solidFill>
+          </a:ln>
+        </p:spPr>
+      </p:pic>
+      <p:sp>
+        <p:nvSpPr>
+          <p:cNvPr id="16" name="TextBox 15"/>
+          <p:cNvSpPr txBox="1"/>
+          <p:nvPr/>
+        </p:nvSpPr>
+        <p:spPr>
+          <a:xfrm>
+            <a:off x="6187287" y="5989320"/>
+            <a:ext cx="5455767" cy="320040"/>
+          </a:xfrm>
+          <a:prstGeom prst="rect">
+            <a:avLst/>
+          </a:prstGeom>
+          <a:noFill/>
+        </p:spPr>
+        <p:txBody>
+          <a:bodyPr wrap="none">
+            <a:spAutoFit/>
+          </a:bodyPr>
+          <a:lstStyle/>
+          <a:p>
+            <a:r>
+              <a:rPr sz="1200" b="1"/>
+              <a:t>관리자 수집 모니터링 (SC-08)</a:t>
             </a:r>
           </a:p>
         </p:txBody>
@@ -9390,7 +9928,7 @@
                 <a:ea typeface="맑은 고딕"/>
                 <a:cs typeface="맑은 고딕"/>
               </a:rPr>
-              <a:t>트래블핏(TravelFit) · Semi-Project · 3조</a:t>
+              <a:t>노마드픽(NomadPick) · Semi-Project · 3조</a:t>
             </a:r>
           </a:p>
         </p:txBody>
@@ -10955,7 +11493,7 @@
                 <a:ea typeface="맑은 고딕"/>
                 <a:cs typeface="맑은 고딕"/>
               </a:rPr>
-              <a:t>트래블핏(TravelFit) · Semi-Project · 3조</a:t>
+              <a:t>노마드픽(NomadPick) · Semi-Project · 3조</a:t>
             </a:r>
           </a:p>
         </p:txBody>
@@ -12042,7 +12580,7 @@
                 <a:ea typeface="맑은 고딕"/>
                 <a:cs typeface="맑은 고딕"/>
               </a:rPr>
-              <a:t>트래블핏(TravelFit) · Semi-Project · 3조</a:t>
+              <a:t>노마드픽(NomadPick) · Semi-Project · 3조</a:t>
             </a:r>
           </a:p>
         </p:txBody>
@@ -12485,7 +13023,7 @@
                           <a:ea typeface="맑은 고딕"/>
                           <a:cs typeface="맑은 고딕"/>
                         </a:rPr>
-                        <a:t>가격 추이(Plotly), 여행경보, 원문 링크</a:t>
+                        <a:t>가격 추이(Plotly), 국내선 항공편, 원문 링크</a:t>
                       </a:r>
                     </a:p>
                   </a:txBody>
@@ -12998,7 +13536,7 @@
                 <a:ea typeface="맑은 고딕"/>
                 <a:cs typeface="맑은 고딕"/>
               </a:rPr>
-              <a:t>여행경보 없는 지역의 효도 패키지 비교</a:t>
+              <a:t>효도 패키지·국내선 항공편 시간 비교</a:t>
             </a:r>
           </a:p>
         </p:txBody>
@@ -13262,7 +13800,7 @@
                 <a:ea typeface="맑은 고딕"/>
                 <a:cs typeface="맑은 고딕"/>
               </a:rPr>
-              <a:t>트래블핏(TravelFit) · Semi-Project · 3조</a:t>
+              <a:t>노마드픽(NomadPick) · Semi-Project · 3조</a:t>
             </a:r>
           </a:p>
         </p:txBody>
@@ -13474,7 +14012,7 @@
                           <a:ea typeface="맑은 고딕"/>
                           <a:cs typeface="맑은 고딕"/>
                         </a:rPr>
-                        <a:t>일정·위험 관리, FastAPI 20개 API, 인증, Render·EC2 배포, CI/CD</a:t>
+                        <a:t>일정·위험 관리, FastAPI 20개 API, 인증, Docker·Render·EC2 배포, CI/CD</a:t>
                       </a:r>
                     </a:p>
                   </a:txBody>
@@ -13628,7 +14166,7 @@
                           <a:ea typeface="맑은 고딕"/>
                           <a:cs typeface="맑은 고딕"/>
                         </a:rPr>
-                        <a:t>화면 8개(HTML5·Vanilla JS·Bootstrap 5), Plotly 차트, 사용자 테스트</a:t>
+                        <a:t>화면 8개(HTML5·Vanilla JS·Bootstrap 5), Plotly 차트, Netlify 배포</a:t>
                       </a:r>
                     </a:p>
                   </a:txBody>
@@ -13705,7 +14243,7 @@
                           <a:ea typeface="맑은 고딕"/>
                           <a:cs typeface="맑은 고딕"/>
                         </a:rPr>
-                        <a:t>여행사 3곳 수집기(Requests·BS4), 공공데이터 연동, EC2 cron</a:t>
+                        <a:t>여행사 3곳 수집기(Playwright·BS4), 국토교통부 API 연동, 스케줄러</a:t>
                       </a:r>
                     </a:p>
                   </a:txBody>
@@ -14748,7 +15286,7 @@
                 <a:ea typeface="맑은 고딕"/>
                 <a:cs typeface="맑은 고딕"/>
               </a:rPr>
-              <a:t>Render + AWS EC2 + TiDB</a:t>
+              <a:t>Netlify + Render + EC2 + TiDB</a:t>
             </a:r>
           </a:p>
         </p:txBody>
@@ -14824,7 +15362,7 @@
                 <a:ea typeface="맑은 고딕"/>
                 <a:cs typeface="맑은 고딕"/>
               </a:rPr>
-              <a:t>트래블핏(TravelFit) · Semi-Project · 3조</a:t>
+              <a:t>노마드픽(NomadPick) · Semi-Project · 3조</a:t>
             </a:r>
           </a:p>
         </p:txBody>
@@ -14872,14 +15410,14 @@
       </p:sp>
       <p:pic>
         <p:nvPicPr>
-          <p:cNvPr id="9" name="Picture 8" descr="2178131c30ff.png"/>
+          <p:cNvPr id="11" name="Picture 10" descr="image.png"/>
           <p:cNvPicPr>
             <a:picLocks noChangeAspect="1"/>
           </p:cNvPicPr>
           <p:nvPr/>
         </p:nvPicPr>
         <p:blipFill>
-          <a:blip r:embed="rId3"/>
+          <a:blip r:embed="rId4"/>
           <a:stretch>
             <a:fillRect/>
           </a:stretch>
@@ -14887,7 +15425,7 @@
         <p:spPr>
           <a:xfrm>
             <a:off x="569027" y="1371600"/>
-            <a:ext cx="7274426" cy="4937760"/>
+            <a:ext cx="7274426" cy="4639738"/>
           </a:xfrm>
           <a:prstGeom prst="rect">
             <a:avLst/>
@@ -14992,7 +15530,7 @@
                 <a:ea typeface="맑은 고딕"/>
                 <a:cs typeface="맑은 고딕"/>
               </a:rPr>
-              <a:t>  Python 3.11 FastAPI (Render)</a:t>
+              <a:t>  Python 3.11.9 FastAPI (Render → EC2, Docker)</a:t>
             </a:r>
           </a:p>
           <a:p>
@@ -15072,7 +15610,7 @@
                 <a:ea typeface="맑은 고딕"/>
                 <a:cs typeface="맑은 고딕"/>
               </a:rPr>
-              <a:t>  Python 3.11.9 · Requests · BS4 (EC2 cron)</a:t>
+              <a:t>  Python 3.11.9 · Playwright · BS4 (APScheduler)</a:t>
             </a:r>
           </a:p>
           <a:p>
@@ -15112,7 +15650,7 @@
                 <a:ea typeface="맑은 고딕"/>
                 <a:cs typeface="맑은 고딕"/>
               </a:rPr>
-              <a:t>  외교부 여행경보 · 수출입은행 환율</a:t>
+              <a:t>  국토교통부 국내항공운항정보(TAGO)</a:t>
             </a:r>
           </a:p>
         </p:txBody>
@@ -15376,7 +15914,7 @@
                 <a:ea typeface="맑은 고딕"/>
                 <a:cs typeface="맑은 고딕"/>
               </a:rPr>
-              <a:t>트래블핏(TravelFit) · Semi-Project · 3조</a:t>
+              <a:t>노마드픽(NomadPick) · Semi-Project · 3조</a:t>
             </a:r>
           </a:p>
         </p:txBody>
@@ -15588,7 +16126,7 @@
                           <a:ea typeface="맑은 고딕"/>
                           <a:cs typeface="맑은 고딕"/>
                         </a:rPr>
-                        <a:t>여행사 3곳 특가 페이지 요청(2초 간격) → BeautifulSoup4 파싱 → pandas 정제 → 일괄 등록</a:t>
+                        <a:t>Playwright로 홈 → 특가 페이지(2초 간격) → BeautifulSoup4/JSON 파싱 → pandas 정제 → 일괄 등록</a:t>
                       </a:r>
                     </a:p>
                   </a:txBody>
@@ -15615,7 +16153,7 @@
                           <a:ea typeface="맑은 고딕"/>
                           <a:cs typeface="맑은 고딕"/>
                         </a:rPr>
-                        <a:t>BOT-02 공공데이터</a:t>
+                        <a:t>BOT-02 국토교통부 API</a:t>
                       </a:r>
                     </a:p>
                   </a:txBody>
@@ -15665,7 +16203,7 @@
                           <a:ea typeface="맑은 고딕"/>
                           <a:cs typeface="맑은 고딕"/>
                         </a:rPr>
-                        <a:t>외교부 여행경보 · 수출입은행 환율 수집 → 국가 코드 매핑 → 갱신</a:t>
+                        <a:t>공항 목록·국내 상품 출발일 국내선 운항정보 수집 → 공항 ID 매핑 → 갱신</a:t>
                       </a:r>
                     </a:p>
                   </a:txBody>
@@ -15815,7 +16353,7 @@
                 <a:ea typeface="맑은 고딕"/>
                 <a:cs typeface="맑은 고딕"/>
               </a:rPr>
-              <a:t>  여행사별 CSS 셀렉터를 selectors.json으로 분리 → 페이지 변경에 빠르게 대응</a:t>
+              <a:t>  여행사별 CSS 셀렉터를 selectors.json으로 분리, 홈에서 현재 특가 기획전 자동 탐색</a:t>
             </a:r>
           </a:p>
           <a:p>
@@ -15895,7 +16433,7 @@
                 <a:ea typeface="맑은 고딕"/>
                 <a:cs typeface="맑은 고딕"/>
               </a:rPr>
-              <a:t>  robots.txt 허용 경로만, User-Agent 명시, 상품명·가격 등 사실 정보만 저장</a:t>
+              <a:t>  robots.txt(RFC 9309) 준수, 사람과 같은 브라우저(Playwright) 접근, 상품명·가격 등 사실 정보만 저장</a:t>
             </a:r>
           </a:p>
         </p:txBody>
@@ -16159,7 +16697,7 @@
                 <a:ea typeface="맑은 고딕"/>
                 <a:cs typeface="맑은 고딕"/>
               </a:rPr>
-              <a:t>트래블핏(TravelFit) · Semi-Project · 3조</a:t>
+              <a:t>노마드픽(NomadPick) · Semi-Project · 3조</a:t>
             </a:r>
           </a:p>
         </p:txBody>
@@ -16207,14 +16745,14 @@
       </p:sp>
       <p:pic>
         <p:nvPicPr>
-          <p:cNvPr id="9" name="Picture 8" descr="8f9db25f23e8.png"/>
+          <p:cNvPr id="10" name="Picture 9" descr="image.png"/>
           <p:cNvPicPr>
             <a:picLocks noChangeAspect="1"/>
           </p:cNvPicPr>
           <p:nvPr/>
         </p:nvPicPr>
         <p:blipFill>
-          <a:blip r:embed="rId3"/>
+          <a:blip r:embed="rId4"/>
           <a:stretch>
             <a:fillRect/>
           </a:stretch>
@@ -16222,7 +16760,7 @@
         <p:spPr>
           <a:xfrm>
             <a:off x="1698498" y="1371600"/>
-            <a:ext cx="8764524" cy="4937760"/>
+            <a:ext cx="8764524" cy="4443228"/>
           </a:xfrm>
           <a:prstGeom prst="rect">
             <a:avLst/>
@@ -16488,7 +17026,7 @@
                 <a:ea typeface="맑은 고딕"/>
                 <a:cs typeface="맑은 고딕"/>
               </a:rPr>
-              <a:t>트래블핏(TravelFit) · Semi-Project · 3조</a:t>
+              <a:t>노마드픽(NomadPick) · Semi-Project · 3조</a:t>
             </a:r>
           </a:p>
         </p:txBody>
@@ -16645,7 +17183,7 @@
                 <a:ea typeface="맑은 고딕"/>
                 <a:cs typeface="맑은 고딕"/>
               </a:rPr>
-              <a:t>선호 유사도: 상품 피처와 선호 벡터의 코사인 유사도 · 여행경보 3단계 이상·잔여석 0 상품은 제외 (생성형 AI 미사용)</a:t>
+              <a:t>선호 유사도: 상품 피처와 선호 벡터의 코사인 유사도 · 잔여석 0·출발 경과 상품 제외, 동일 도시 최대 2건 (생성형 AI 미사용)</a:t>
             </a:r>
           </a:p>
         </p:txBody>
@@ -16776,7 +17314,7 @@
                 <a:ea typeface="맑은 고딕"/>
                 <a:cs typeface="맑은 고딕"/>
               </a:rPr>
-              <a:t>1,850건</a:t>
+              <a:t>8,800건</a:t>
             </a:r>
           </a:p>
         </p:txBody>
@@ -16858,7 +17396,7 @@
                 <a:ea typeface="맑은 고딕"/>
                 <a:cs typeface="맑은 고딕"/>
               </a:rPr>
-              <a:t>3개 여행사, 고유 상품 약 620개</a:t>
+              <a:t>3개 여행사, 고유 상품 약 330개</a:t>
             </a:r>
           </a:p>
         </p:txBody>

</xml_diff>